<commit_message>
EVM1110E: đối chiếu Bài 1–3 với Drakeley, Korstanje và giáo trình Implementing KAM đầy đủ
- W01: ví dụ lễ hội âm nhạc (Drakeley), Todd 2017, rủi ro Reid 2011, slide Nguyên tắc Clarkson
- W02: vòng đời khách hàng (Buttle qua Drakeley), ca agency Drakeley, sửa số trang giáo trình
- W03: GRASP xác nhận theo Bảng 4.1 tr. 107, mẹo để G sau cùng; vai Controller (Hình 4.6); Hình 4.5; 2 slide kỳ vọng
- Ghi tư liệu buổi 1–3 và source_map

Co-Authored-By: Claude Opus 5.5 <noreply@anthropic.com>
Claude-Session: https://claude.ai/code/session_014QwQ68qeN46CsLnynfoTqG
</commit_message>
<xml_diff>
--- a/courses/EVM1110E/slides/W01_slides.pptx
+++ b/courses/EVM1110E/slides/W01_slides.pptx
@@ -3368,10 +3368,10 @@
           <a:p>
             <a:r>
               <a:rPr lang="en-US" dirty="0"/>
-              <a:t>Nói: Một phát hiện đáng suy nghĩ: Wallace và Michopoulou, 2019, phỏng vấn người làm nghề sự kiện và thấy không mô hình bên liên quan quen thuộc nào — kể cả các mô hình riêng cho sự kiện — được dùng phổ biến trong thực tế; nhưng định nghĩa của Freeman năm 1984 vẫn đúng. Họ đề xuất Stakeholder Sandwich — chiếc bánh kẹp: lớp trên là affectors — bên có thể ảnh hưởng đến sự kiện; lớp dưới là affectees — bên bị sự kiện ảnh hưởng; và ở giữa là chính sự kiện, địa điểm và thời gian. Mỗi bên ghi thêm điều họ quan tâm chính: outputs — kết quả đo được như số khách, doanh thu; hay outcomes — tác động định tính như hình ảnh, cộng đồng, trải nghiệm. Mô hình được thử trên Tour de Yorkshire. Ý nghĩa cho các bạn: công cụ chỉ có giá trị khi dùng được; nếu Grid hay Salience khó áp dụng, Sandwich là một cách vẽ đơn giản hơn.
-(GV: Đã đối chiếu bản tác giả do GV cung cấp: Wallace &amp; Michopoulou (2019), “The stakeholder sandwich: A new stakeholder analysis model for events and festivals”, Event Management, DOI 10.3727/152599519X15506259855742 — tóm tắt (không mô hình nào “in common usage”, Freeman 1984 “continues to be valid”) và Hình 7 (affector/affectee × output/outcome, sự kiện–địa điểm–thời gian ở giữa). [VERIFY: số tập/kỳ/trang bản in.] Bài tiếp theo của cùng tác giả (Wallace &amp; Michopoulou, 2023, Event Management 27, 281–299) dùng Sandwich để đo thành công theo cách của từng bên — để dành cho Buổi 5, 8, 12. Slide là tùy chọn: nếu thiếu giờ, bỏ slide này.)
+              <a:t>Nói: Một phát hiện đáng suy nghĩ: Wallace và Michopoulou, 2019, phỏng vấn người làm nghề sự kiện và thấy không mô hình bên liên quan quen thuộc nào được dùng phổ biến trong thực tế; nhưng định nghĩa của Freeman năm 1984 vẫn đúng. Họ đề xuất Stakeholder Sandwich — chiếc bánh kẹp. Lớp trên là affectors — bên có thể ảnh hưởng đến sự kiện; lớp dưới là affectees — bên bị sự kiện ảnh hưởng; ở giữa là chính sự kiện, địa điểm và thời gian. Mỗi bên được ghi theo điều họ quan tâm: outputs — kết quả đo được; hay outcomes — tác động định tính. Ví dụ một lễ hội âm nhạc ba ngày trên bãi cỏ vào tháng 9: chính quyền là affector quan tâm output — cấp phép, an toàn; địa điểm là affector quan tâm outcome — hình ảnh, khán giả; cư dân là affectee quan tâm output — tiếng ồn, giao thông; khán giả là affectee quan tâm outcome — trải nghiệm, giao lưu. Từ đó, với cư dân, ban tổ chức có thể chọn cách hợp tác và thông tin sớm, chính xác.
+(GV: Đã đối chiếu: Wallace &amp; Michopoulou (2019), Event Management, DOI 10.3727/152599519X15506259855742 — tóm tắt và Hình 7 [VERIFY: số tập/kỳ/trang bản in]. Ví dụ lễ hội âm nhạc là Hình 3 trong chương của Drakeley (2022) “Managing event stakeholders: Expect the unexpected” (tài liệu GV cung cấp) — Drakeley mô tả Sandwich là bước phát triển từ Salience Model, vì bên liên quan sự kiện hiếm khi đứng yên ở một nhóm. Bài 2023 của cùng tác giả để dành cho Buổi 5, 8, 12. Slide tùy chọn: nếu thiếu giờ, bỏ.)
 Hỏi lớp: “Trong hội nghị An Phát, cư dân là affector hay affectee? Có thể là cả hai không?”
-Chuyển ý: Hai công cụ — hay ba — là bước đầu của một việc làm liên tục.</a:t>
+Chuyển ý: Các công cụ này là bước đầu của một việc làm liên tục.</a:t>
             </a:r>
             <a:endParaRPr lang="en-US" dirty="0"/>
           </a:p>
@@ -3732,8 +3732,8 @@
           <a:p>
             <a:r>
               <a:rPr lang="en-US" dirty="0"/>
-              <a:t>Nói: Một điều về đạo đức nghề nghiệp. Có hai loại cam kết với bên liên quan. Có hợp đồng: quyền lợi ghi rõ, bên kia có thể đòi theo luật. Chỉ là lời hứa: không kiện được, nhưng mất uy tín — như chủ quầy pizza ở Fremantle: “Họ hứa 200.000 người…”. Uy tín mất rồi thì sự kiện sau không ai tham gia. Nguyên tắc: chỉ hứa điều mình kiểm soát được, và ghi lại điều đã hứa.
-(GV: Ý “legal stake / moral stake” lấy từ video Boateng (2021) qua NotebookLM — chưa đối chiếu, dùng ở mức ý tưởng, không trích tên; ý “rủi ro” liên quan đã có nguồn ở slide 21 (Reid, 2011). Nối CLO8 (đạo đức và trách nhiệm nghề nghiệp). Không rõ trong sách ai đã hứa con số 200.000 với người bán hàng — đừng khẳng định đó là ban tổ chức.)
+              <a:t>Nói: Một điều về đạo đức nghề nghiệp. Các Nguyên tắc Clarkson về quản trị bên liên quan nêu bốn việc: thừa nhận và theo dõi chủ động các bên; lắng nghe và trao đổi với họ; điều chỉnh hành vi theo nhu cầu của họ; và thừa nhận sự phụ thuộc lẫn nhau, coi trọng hợp tác. Với sự kiện — một hoạt động diễn ra trước công chúng — các nguyên tắc này càng quan trọng. Và một bài học từ Fremantle: chủ quầy pizza nói “Họ hứa 200.000 người… Họ đâu rồi?”. Lời hứa không có hợp đồng thì không kiện được — nhưng mất uy tín. Chỉ hứa điều mình kiểm soát được, và ghi lại điều đã hứa.
+(GV: Nguyên tắc Clarkson: theo Drakeley (2022), chương do GV cung cấp, dẫn Maines (2018) — chưa đọc bản gốc nguyên tắc [VERIFY: Clarkson Centre for Business Ethics (1999), Principles of Stakeholder Management — bản gốc có 7 nguyên tắc; slide chỉ dùng 4 ý Drakeley nêu]. Thay cho ý “legal/moral stake” từ video Boateng (chưa đối chiếu được). Không rõ trong sách ai đã hứa con số 200.000 — đừng khẳng định đó là ban tổ chức. Nối CLO8.)
 Hỏi lớp: “Trong dự án cũ, nhóm đã từng hứa điều gì với một bên mà không chắc làm được?”
 Chuyển ý: Giờ áp dụng tất cả lên khách hàng thật của nhóm: Thực hành 2.</a:t>
             </a:r>
@@ -27401,18 +27401,96 @@
       </p:sp>
       <p:sp>
         <p:nvSpPr>
-          <p:cNvPr id="3" name="Shape 1"/>
+          <p:cNvPr id="3" name="Text 1"/>
+          <p:cNvSpPr txBox="1"/>
+          <p:nvPr/>
+        </p:nvSpPr>
+        <p:spPr>
+          <a:xfrm>
+            <a:off x="2926080" y="1645920"/>
+            <a:ext cx="4206240" cy="411480"/>
+          </a:xfrm>
+          <a:prstGeom prst="rect">
+            <a:avLst/>
+          </a:prstGeom>
+          <a:noFill/>
+          <a:ln/>
+        </p:spPr>
+        <p:txBody>
+          <a:bodyPr wrap="square" lIns="635" tIns="635" rIns="635" bIns="635" rtlCol="0" anchor="ctr"/>
+          <a:lstStyle/>
+          <a:p>
+            <a:pPr algn="ctr" indent="0" marL="0">
+              <a:buNone/>
+            </a:pPr>
+            <a:r>
+              <a:rPr lang="en-US" sz="1500" b="1" dirty="0">
+                <a:solidFill>
+                  <a:srgbClr val="09A1E5"/>
+                </a:solidFill>
+                <a:latin typeface="Alexandria" pitchFamily="34" charset="0"/>
+                <a:ea typeface="Alexandria" pitchFamily="34" charset="-122"/>
+                <a:cs typeface="Alexandria" pitchFamily="34" charset="-120"/>
+              </a:rPr>
+              <a:t>Outputs — kết quả đo được</a:t>
+            </a:r>
+            <a:endParaRPr lang="en-US" sz="1500" dirty="0"/>
+          </a:p>
+        </p:txBody>
+      </p:sp>
+      <p:sp>
+        <p:nvSpPr>
+          <p:cNvPr id="4" name="Text 2"/>
+          <p:cNvSpPr txBox="1"/>
+          <p:nvPr/>
+        </p:nvSpPr>
+        <p:spPr>
+          <a:xfrm>
+            <a:off x="7315200" y="1645920"/>
+            <a:ext cx="4297680" cy="411480"/>
+          </a:xfrm>
+          <a:prstGeom prst="rect">
+            <a:avLst/>
+          </a:prstGeom>
+          <a:noFill/>
+          <a:ln/>
+        </p:spPr>
+        <p:txBody>
+          <a:bodyPr wrap="square" lIns="635" tIns="635" rIns="635" bIns="635" rtlCol="0" anchor="ctr"/>
+          <a:lstStyle/>
+          <a:p>
+            <a:pPr algn="ctr" indent="0" marL="0">
+              <a:buNone/>
+            </a:pPr>
+            <a:r>
+              <a:rPr lang="en-US" sz="1500" b="1" dirty="0">
+                <a:solidFill>
+                  <a:srgbClr val="FF9259"/>
+                </a:solidFill>
+                <a:latin typeface="Alexandria" pitchFamily="34" charset="0"/>
+                <a:ea typeface="Alexandria" pitchFamily="34" charset="-122"/>
+                <a:cs typeface="Alexandria" pitchFamily="34" charset="-120"/>
+              </a:rPr>
+              <a:t>Outcomes — tác động định tính</a:t>
+            </a:r>
+            <a:endParaRPr lang="en-US" sz="1500" dirty="0"/>
+          </a:p>
+        </p:txBody>
+      </p:sp>
+      <p:sp>
+        <p:nvSpPr>
+          <p:cNvPr id="5" name="Shape 3"/>
           <p:cNvSpPr/>
           <p:nvPr/>
         </p:nvSpPr>
         <p:spPr>
           <a:xfrm>
-            <a:off x="548640" y="1783080"/>
-            <a:ext cx="6675120" cy="1143000"/>
+            <a:off x="548640" y="2148840"/>
+            <a:ext cx="2194560" cy="1051560"/>
           </a:xfrm>
           <a:prstGeom prst="roundRect">
             <a:avLst>
-              <a:gd name="adj" fmla="val 6400"/>
+              <a:gd name="adj" fmla="val 6957"/>
             </a:avLst>
           </a:prstGeom>
           <a:solidFill>
@@ -27428,14 +27506,14 @@
       </p:sp>
       <p:sp>
         <p:nvSpPr>
-          <p:cNvPr id="4" name="Text 2"/>
-          <p:cNvSpPr txBox="1"/>
-          <p:nvPr/>
-        </p:nvSpPr>
-        <p:spPr>
-          <a:xfrm>
-            <a:off x="777240" y="1783080"/>
-            <a:ext cx="6309360" cy="1143000"/>
+          <p:cNvPr id="6" name="Text 4"/>
+          <p:cNvSpPr txBox="1"/>
+          <p:nvPr/>
+        </p:nvSpPr>
+        <p:spPr>
+          <a:xfrm>
+            <a:off x="640080" y="2148840"/>
+            <a:ext cx="2011680" cy="1051560"/>
           </a:xfrm>
           <a:prstGeom prst="rect">
             <a:avLst/>
@@ -27447,11 +27525,11 @@
           <a:bodyPr wrap="square" lIns="635" tIns="635" rIns="635" bIns="635" rtlCol="0" anchor="ctr"/>
           <a:lstStyle/>
           <a:p>
-            <a:pPr indent="0" marL="0">
-              <a:buNone/>
-            </a:pPr>
-            <a:r>
-              <a:rPr lang="en-US" sz="1800" b="1" dirty="0">
+            <a:pPr algn="ctr" indent="0" marL="0">
+              <a:buNone/>
+            </a:pPr>
+            <a:r>
+              <a:rPr lang="en-US" sz="1500" b="1" dirty="0">
                 <a:solidFill>
                   <a:srgbClr val="172849"/>
                 </a:solidFill>
@@ -27459,26 +27537,175 @@
                 <a:ea typeface="Alexandria" pitchFamily="34" charset="-122"/>
                 <a:cs typeface="Alexandria" pitchFamily="34" charset="-120"/>
               </a:rPr>
-              <a:t>Affectors — bên có thể ảnh hưởng đến sự kiện</a:t>
-            </a:r>
-            <a:endParaRPr lang="en-US" sz="1800" dirty="0"/>
-          </a:p>
-        </p:txBody>
-      </p:sp>
-      <p:sp>
-        <p:nvSpPr>
-          <p:cNvPr id="5" name="Shape 3"/>
+              <a:t>Affectors</a:t>
+            </a:r>
+            <a:endParaRPr lang="en-US" sz="1500" dirty="0"/>
+          </a:p>
+          <a:p>
+            <a:pPr algn="ctr" indent="0" marL="0">
+              <a:buNone/>
+            </a:pPr>
+            <a:r>
+              <a:rPr lang="en-US" sz="1500" b="1" dirty="0">
+                <a:solidFill>
+                  <a:srgbClr val="172849"/>
+                </a:solidFill>
+                <a:latin typeface="Alexandria" pitchFamily="34" charset="0"/>
+                <a:ea typeface="Alexandria" pitchFamily="34" charset="-122"/>
+                <a:cs typeface="Alexandria" pitchFamily="34" charset="-120"/>
+              </a:rPr>
+              <a:t>(có thể ảnh hưởng)</a:t>
+            </a:r>
+            <a:endParaRPr lang="en-US" sz="1500" dirty="0"/>
+          </a:p>
+        </p:txBody>
+      </p:sp>
+      <p:sp>
+        <p:nvSpPr>
+          <p:cNvPr id="7" name="Shape 5"/>
           <p:cNvSpPr/>
           <p:nvPr/>
         </p:nvSpPr>
         <p:spPr>
           <a:xfrm>
-            <a:off x="548640" y="3063240"/>
-            <a:ext cx="6675120" cy="1143000"/>
+            <a:off x="2926080" y="2148840"/>
+            <a:ext cx="4206240" cy="1051560"/>
           </a:xfrm>
           <a:prstGeom prst="roundRect">
             <a:avLst>
-              <a:gd name="adj" fmla="val 6400"/>
+              <a:gd name="adj" fmla="val 6957"/>
+            </a:avLst>
+          </a:prstGeom>
+          <a:solidFill>
+            <a:srgbClr val="22395F"/>
+          </a:solidFill>
+          <a:ln w="12700">
+            <a:solidFill>
+              <a:srgbClr val="22395F"/>
+            </a:solidFill>
+            <a:prstDash val="solid"/>
+          </a:ln>
+        </p:spPr>
+      </p:sp>
+      <p:sp>
+        <p:nvSpPr>
+          <p:cNvPr id="8" name="Text 6"/>
+          <p:cNvSpPr txBox="1"/>
+          <p:nvPr/>
+        </p:nvSpPr>
+        <p:spPr>
+          <a:xfrm>
+            <a:off x="3108960" y="2148840"/>
+            <a:ext cx="3840480" cy="1051560"/>
+          </a:xfrm>
+          <a:prstGeom prst="rect">
+            <a:avLst/>
+          </a:prstGeom>
+          <a:noFill/>
+          <a:ln/>
+        </p:spPr>
+        <p:txBody>
+          <a:bodyPr wrap="square" lIns="635" tIns="635" rIns="635" bIns="635" rtlCol="0" anchor="ctr"/>
+          <a:lstStyle/>
+          <a:p>
+            <a:pPr indent="0" marL="0">
+              <a:buNone/>
+            </a:pPr>
+            <a:r>
+              <a:rPr lang="en-US" sz="1600" dirty="0">
+                <a:solidFill>
+                  <a:srgbClr val="FBFAF4"/>
+                </a:solidFill>
+                <a:latin typeface="Alexandria" pitchFamily="34" charset="0"/>
+                <a:ea typeface="Alexandria" pitchFamily="34" charset="-122"/>
+                <a:cs typeface="Alexandria" pitchFamily="34" charset="-120"/>
+              </a:rPr>
+              <a:t>Chính quyền: cấp phép, an toàn</a:t>
+            </a:r>
+            <a:endParaRPr lang="en-US" sz="1600" dirty="0"/>
+          </a:p>
+        </p:txBody>
+      </p:sp>
+      <p:sp>
+        <p:nvSpPr>
+          <p:cNvPr id="9" name="Shape 7"/>
+          <p:cNvSpPr/>
+          <p:nvPr/>
+        </p:nvSpPr>
+        <p:spPr>
+          <a:xfrm>
+            <a:off x="7315200" y="2148840"/>
+            <a:ext cx="4325112" cy="1051560"/>
+          </a:xfrm>
+          <a:prstGeom prst="roundRect">
+            <a:avLst>
+              <a:gd name="adj" fmla="val 6957"/>
+            </a:avLst>
+          </a:prstGeom>
+          <a:solidFill>
+            <a:srgbClr val="22395F"/>
+          </a:solidFill>
+          <a:ln w="12700">
+            <a:solidFill>
+              <a:srgbClr val="22395F"/>
+            </a:solidFill>
+            <a:prstDash val="solid"/>
+          </a:ln>
+        </p:spPr>
+      </p:sp>
+      <p:sp>
+        <p:nvSpPr>
+          <p:cNvPr id="10" name="Text 8"/>
+          <p:cNvSpPr txBox="1"/>
+          <p:nvPr/>
+        </p:nvSpPr>
+        <p:spPr>
+          <a:xfrm>
+            <a:off x="7498080" y="2148840"/>
+            <a:ext cx="3977640" cy="1051560"/>
+          </a:xfrm>
+          <a:prstGeom prst="rect">
+            <a:avLst/>
+          </a:prstGeom>
+          <a:noFill/>
+          <a:ln/>
+        </p:spPr>
+        <p:txBody>
+          <a:bodyPr wrap="square" lIns="635" tIns="635" rIns="635" bIns="635" rtlCol="0" anchor="ctr"/>
+          <a:lstStyle/>
+          <a:p>
+            <a:pPr indent="0" marL="0">
+              <a:buNone/>
+            </a:pPr>
+            <a:r>
+              <a:rPr lang="en-US" sz="1600" dirty="0">
+                <a:solidFill>
+                  <a:srgbClr val="FBFAF4"/>
+                </a:solidFill>
+                <a:latin typeface="Alexandria" pitchFamily="34" charset="0"/>
+                <a:ea typeface="Alexandria" pitchFamily="34" charset="-122"/>
+                <a:cs typeface="Alexandria" pitchFamily="34" charset="-120"/>
+              </a:rPr>
+              <a:t>Địa điểm: hình ảnh, khán giả</a:t>
+            </a:r>
+            <a:endParaRPr lang="en-US" sz="1600" dirty="0"/>
+          </a:p>
+        </p:txBody>
+      </p:sp>
+      <p:sp>
+        <p:nvSpPr>
+          <p:cNvPr id="11" name="Shape 9"/>
+          <p:cNvSpPr/>
+          <p:nvPr/>
+        </p:nvSpPr>
+        <p:spPr>
+          <a:xfrm>
+            <a:off x="548640" y="3383280"/>
+            <a:ext cx="2194560" cy="1051560"/>
+          </a:xfrm>
+          <a:prstGeom prst="roundRect">
+            <a:avLst>
+              <a:gd name="adj" fmla="val 6957"/>
             </a:avLst>
           </a:prstGeom>
           <a:solidFill>
@@ -27494,14 +27721,14 @@
       </p:sp>
       <p:sp>
         <p:nvSpPr>
-          <p:cNvPr id="6" name="Text 4"/>
-          <p:cNvSpPr txBox="1"/>
-          <p:nvPr/>
-        </p:nvSpPr>
-        <p:spPr>
-          <a:xfrm>
-            <a:off x="777240" y="3063240"/>
-            <a:ext cx="6309360" cy="1143000"/>
+          <p:cNvPr id="12" name="Text 10"/>
+          <p:cNvSpPr txBox="1"/>
+          <p:nvPr/>
+        </p:nvSpPr>
+        <p:spPr>
+          <a:xfrm>
+            <a:off x="640080" y="3383280"/>
+            <a:ext cx="2011680" cy="1051560"/>
           </a:xfrm>
           <a:prstGeom prst="rect">
             <a:avLst/>
@@ -27513,11 +27740,11 @@
           <a:bodyPr wrap="square" lIns="635" tIns="635" rIns="635" bIns="635" rtlCol="0" anchor="ctr"/>
           <a:lstStyle/>
           <a:p>
-            <a:pPr indent="0" marL="0">
-              <a:buNone/>
-            </a:pPr>
-            <a:r>
-              <a:rPr lang="en-US" sz="1800" b="1" dirty="0">
+            <a:pPr algn="ctr" indent="0" marL="0">
+              <a:buNone/>
+            </a:pPr>
+            <a:r>
+              <a:rPr lang="en-US" sz="1500" b="1" dirty="0">
                 <a:solidFill>
                   <a:srgbClr val="172849"/>
                 </a:solidFill>
@@ -27525,26 +27752,92 @@
                 <a:ea typeface="Alexandria" pitchFamily="34" charset="-122"/>
                 <a:cs typeface="Alexandria" pitchFamily="34" charset="-120"/>
               </a:rPr>
-              <a:t>Sự kiện · địa điểm · thời gian (ở giữa)</a:t>
-            </a:r>
-            <a:endParaRPr lang="en-US" sz="1800" dirty="0"/>
-          </a:p>
-        </p:txBody>
-      </p:sp>
-      <p:sp>
-        <p:nvSpPr>
-          <p:cNvPr id="7" name="Shape 5"/>
+              <a:t>Sự kiện · địa điểm · thời gian</a:t>
+            </a:r>
+            <a:endParaRPr lang="en-US" sz="1500" dirty="0"/>
+          </a:p>
+        </p:txBody>
+      </p:sp>
+      <p:sp>
+        <p:nvSpPr>
+          <p:cNvPr id="13" name="Shape 11"/>
           <p:cNvSpPr/>
           <p:nvPr/>
         </p:nvSpPr>
         <p:spPr>
           <a:xfrm>
-            <a:off x="548640" y="4343400"/>
-            <a:ext cx="6675120" cy="1143000"/>
+            <a:off x="2926080" y="3383280"/>
+            <a:ext cx="8714232" cy="1051560"/>
           </a:xfrm>
           <a:prstGeom prst="roundRect">
             <a:avLst>
-              <a:gd name="adj" fmla="val 6400"/>
+              <a:gd name="adj" fmla="val 6957"/>
+            </a:avLst>
+          </a:prstGeom>
+          <a:solidFill>
+            <a:srgbClr val="FFD23B"/>
+          </a:solidFill>
+          <a:ln w="12700">
+            <a:solidFill>
+              <a:srgbClr val="FFD23B"/>
+            </a:solidFill>
+            <a:prstDash val="solid"/>
+          </a:ln>
+        </p:spPr>
+      </p:sp>
+      <p:sp>
+        <p:nvSpPr>
+          <p:cNvPr id="14" name="Text 12"/>
+          <p:cNvSpPr txBox="1"/>
+          <p:nvPr/>
+        </p:nvSpPr>
+        <p:spPr>
+          <a:xfrm>
+            <a:off x="3108960" y="3383280"/>
+            <a:ext cx="8321040" cy="1051560"/>
+          </a:xfrm>
+          <a:prstGeom prst="rect">
+            <a:avLst/>
+          </a:prstGeom>
+          <a:noFill/>
+          <a:ln/>
+        </p:spPr>
+        <p:txBody>
+          <a:bodyPr wrap="square" lIns="635" tIns="635" rIns="635" bIns="635" rtlCol="0" anchor="ctr"/>
+          <a:lstStyle/>
+          <a:p>
+            <a:pPr algn="ctr" indent="0" marL="0">
+              <a:buNone/>
+            </a:pPr>
+            <a:r>
+              <a:rPr lang="en-US" sz="1700" b="1" dirty="0">
+                <a:solidFill>
+                  <a:srgbClr val="172849"/>
+                </a:solidFill>
+                <a:latin typeface="Alexandria" pitchFamily="34" charset="0"/>
+                <a:ea typeface="Alexandria" pitchFamily="34" charset="-122"/>
+                <a:cs typeface="Alexandria" pitchFamily="34" charset="-120"/>
+              </a:rPr>
+              <a:t>Lễ hội âm nhạc 3 ngày, bãi cỏ ngoài trời, tháng 9</a:t>
+            </a:r>
+            <a:endParaRPr lang="en-US" sz="1700" dirty="0"/>
+          </a:p>
+        </p:txBody>
+      </p:sp>
+      <p:sp>
+        <p:nvSpPr>
+          <p:cNvPr id="15" name="Shape 13"/>
+          <p:cNvSpPr/>
+          <p:nvPr/>
+        </p:nvSpPr>
+        <p:spPr>
+          <a:xfrm>
+            <a:off x="548640" y="4617720"/>
+            <a:ext cx="2194560" cy="1051560"/>
+          </a:xfrm>
+          <a:prstGeom prst="roundRect">
+            <a:avLst>
+              <a:gd name="adj" fmla="val 6957"/>
             </a:avLst>
           </a:prstGeom>
           <a:solidFill>
@@ -27560,14 +27853,14 @@
       </p:sp>
       <p:sp>
         <p:nvSpPr>
-          <p:cNvPr id="8" name="Text 6"/>
-          <p:cNvSpPr txBox="1"/>
-          <p:nvPr/>
-        </p:nvSpPr>
-        <p:spPr>
-          <a:xfrm>
-            <a:off x="777240" y="4343400"/>
-            <a:ext cx="6309360" cy="1143000"/>
+          <p:cNvPr id="16" name="Text 14"/>
+          <p:cNvSpPr txBox="1"/>
+          <p:nvPr/>
+        </p:nvSpPr>
+        <p:spPr>
+          <a:xfrm>
+            <a:off x="640080" y="4617720"/>
+            <a:ext cx="2011680" cy="1051560"/>
           </a:xfrm>
           <a:prstGeom prst="rect">
             <a:avLst/>
@@ -27579,11 +27872,11 @@
           <a:bodyPr wrap="square" lIns="635" tIns="635" rIns="635" bIns="635" rtlCol="0" anchor="ctr"/>
           <a:lstStyle/>
           <a:p>
-            <a:pPr indent="0" marL="0">
-              <a:buNone/>
-            </a:pPr>
-            <a:r>
-              <a:rPr lang="en-US" sz="1800" b="1" dirty="0">
+            <a:pPr algn="ctr" indent="0" marL="0">
+              <a:buNone/>
+            </a:pPr>
+            <a:r>
+              <a:rPr lang="en-US" sz="1500" b="1" dirty="0">
                 <a:solidFill>
                   <a:srgbClr val="172849"/>
                 </a:solidFill>
@@ -27591,26 +27884,43 @@
                 <a:ea typeface="Alexandria" pitchFamily="34" charset="-122"/>
                 <a:cs typeface="Alexandria" pitchFamily="34" charset="-120"/>
               </a:rPr>
-              <a:t>Affectees — bên bị sự kiện ảnh hưởng</a:t>
-            </a:r>
-            <a:endParaRPr lang="en-US" sz="1800" dirty="0"/>
-          </a:p>
-        </p:txBody>
-      </p:sp>
-      <p:sp>
-        <p:nvSpPr>
-          <p:cNvPr id="9" name="Shape 7"/>
+              <a:t>Affectees</a:t>
+            </a:r>
+            <a:endParaRPr lang="en-US" sz="1500" dirty="0"/>
+          </a:p>
+          <a:p>
+            <a:pPr algn="ctr" indent="0" marL="0">
+              <a:buNone/>
+            </a:pPr>
+            <a:r>
+              <a:rPr lang="en-US" sz="1500" b="1" dirty="0">
+                <a:solidFill>
+                  <a:srgbClr val="172849"/>
+                </a:solidFill>
+                <a:latin typeface="Alexandria" pitchFamily="34" charset="0"/>
+                <a:ea typeface="Alexandria" pitchFamily="34" charset="-122"/>
+                <a:cs typeface="Alexandria" pitchFamily="34" charset="-120"/>
+              </a:rPr>
+              <a:t>(bị ảnh hưởng)</a:t>
+            </a:r>
+            <a:endParaRPr lang="en-US" sz="1500" dirty="0"/>
+          </a:p>
+        </p:txBody>
+      </p:sp>
+      <p:sp>
+        <p:nvSpPr>
+          <p:cNvPr id="17" name="Shape 15"/>
           <p:cNvSpPr/>
           <p:nvPr/>
         </p:nvSpPr>
         <p:spPr>
           <a:xfrm>
-            <a:off x="7498080" y="1783080"/>
-            <a:ext cx="4142232" cy="3703320"/>
+            <a:off x="2926080" y="4617720"/>
+            <a:ext cx="4206240" cy="1051560"/>
           </a:xfrm>
           <a:prstGeom prst="roundRect">
             <a:avLst>
-              <a:gd name="adj" fmla="val 1975"/>
+              <a:gd name="adj" fmla="val 6957"/>
             </a:avLst>
           </a:prstGeom>
           <a:solidFill>
@@ -27626,23 +27936,23 @@
       </p:sp>
       <p:sp>
         <p:nvSpPr>
-          <p:cNvPr id="10" name="Text 8"/>
-          <p:cNvSpPr txBox="1"/>
-          <p:nvPr/>
-        </p:nvSpPr>
-        <p:spPr>
-          <a:xfrm>
-            <a:off x="7726680" y="1920240"/>
-            <a:ext cx="3749040" cy="731520"/>
-          </a:xfrm>
-          <a:prstGeom prst="rect">
-            <a:avLst/>
-          </a:prstGeom>
-          <a:noFill/>
-          <a:ln/>
-        </p:spPr>
-        <p:txBody>
-          <a:bodyPr wrap="square" lIns="635" tIns="635" rIns="635" bIns="635" rtlCol="0" anchor="t"/>
+          <p:cNvPr id="18" name="Text 16"/>
+          <p:cNvSpPr txBox="1"/>
+          <p:nvPr/>
+        </p:nvSpPr>
+        <p:spPr>
+          <a:xfrm>
+            <a:off x="3108960" y="4617720"/>
+            <a:ext cx="3840480" cy="1051560"/>
+          </a:xfrm>
+          <a:prstGeom prst="rect">
+            <a:avLst/>
+          </a:prstGeom>
+          <a:noFill/>
+          <a:ln/>
+        </p:spPr>
+        <p:txBody>
+          <a:bodyPr wrap="square" lIns="635" tIns="635" rIns="635" bIns="635" rtlCol="0" anchor="ctr"/>
           <a:lstStyle/>
           <a:p>
             <a:pPr indent="0" marL="0">
@@ -27651,117 +27961,126 @@
             <a:r>
               <a:rPr lang="en-US" sz="1600" dirty="0">
                 <a:solidFill>
+                  <a:srgbClr val="FBFAF4"/>
+                </a:solidFill>
+                <a:latin typeface="Alexandria" pitchFamily="34" charset="0"/>
+                <a:ea typeface="Alexandria" pitchFamily="34" charset="-122"/>
+                <a:cs typeface="Alexandria" pitchFamily="34" charset="-120"/>
+              </a:rPr>
+              <a:t>Cư dân: tiếng ồn, giao thông</a:t>
+            </a:r>
+            <a:endParaRPr lang="en-US" sz="1600" dirty="0"/>
+          </a:p>
+        </p:txBody>
+      </p:sp>
+      <p:sp>
+        <p:nvSpPr>
+          <p:cNvPr id="19" name="Shape 17"/>
+          <p:cNvSpPr/>
+          <p:nvPr/>
+        </p:nvSpPr>
+        <p:spPr>
+          <a:xfrm>
+            <a:off x="7315200" y="4617720"/>
+            <a:ext cx="4325112" cy="1051560"/>
+          </a:xfrm>
+          <a:prstGeom prst="roundRect">
+            <a:avLst>
+              <a:gd name="adj" fmla="val 6957"/>
+            </a:avLst>
+          </a:prstGeom>
+          <a:solidFill>
+            <a:srgbClr val="22395F"/>
+          </a:solidFill>
+          <a:ln w="12700">
+            <a:solidFill>
+              <a:srgbClr val="22395F"/>
+            </a:solidFill>
+            <a:prstDash val="solid"/>
+          </a:ln>
+        </p:spPr>
+      </p:sp>
+      <p:sp>
+        <p:nvSpPr>
+          <p:cNvPr id="20" name="Text 18"/>
+          <p:cNvSpPr txBox="1"/>
+          <p:nvPr/>
+        </p:nvSpPr>
+        <p:spPr>
+          <a:xfrm>
+            <a:off x="7498080" y="4617720"/>
+            <a:ext cx="3977640" cy="1051560"/>
+          </a:xfrm>
+          <a:prstGeom prst="rect">
+            <a:avLst/>
+          </a:prstGeom>
+          <a:noFill/>
+          <a:ln/>
+        </p:spPr>
+        <p:txBody>
+          <a:bodyPr wrap="square" lIns="635" tIns="635" rIns="635" bIns="635" rtlCol="0" anchor="ctr"/>
+          <a:lstStyle/>
+          <a:p>
+            <a:pPr indent="0" marL="0">
+              <a:buNone/>
+            </a:pPr>
+            <a:r>
+              <a:rPr lang="en-US" sz="1600" dirty="0">
+                <a:solidFill>
+                  <a:srgbClr val="FBFAF4"/>
+                </a:solidFill>
+                <a:latin typeface="Alexandria" pitchFamily="34" charset="0"/>
+                <a:ea typeface="Alexandria" pitchFamily="34" charset="-122"/>
+                <a:cs typeface="Alexandria" pitchFamily="34" charset="-120"/>
+              </a:rPr>
+              <a:t>Khán giả: trải nghiệm, giao lưu</a:t>
+            </a:r>
+            <a:endParaRPr lang="en-US" sz="1600" dirty="0"/>
+          </a:p>
+        </p:txBody>
+      </p:sp>
+      <p:sp>
+        <p:nvSpPr>
+          <p:cNvPr id="21" name="Text 19"/>
+          <p:cNvSpPr txBox="1"/>
+          <p:nvPr/>
+        </p:nvSpPr>
+        <p:spPr>
+          <a:xfrm>
+            <a:off x="8503920" y="5852160"/>
+            <a:ext cx="3108960" cy="365760"/>
+          </a:xfrm>
+          <a:prstGeom prst="rect">
+            <a:avLst/>
+          </a:prstGeom>
+          <a:noFill/>
+          <a:ln/>
+        </p:spPr>
+        <p:txBody>
+          <a:bodyPr wrap="square" lIns="635" tIns="635" rIns="635" bIns="635" rtlCol="0" anchor="ctr"/>
+          <a:lstStyle/>
+          <a:p>
+            <a:pPr algn="r" indent="0" marL="0">
+              <a:buNone/>
+            </a:pPr>
+            <a:r>
+              <a:rPr lang="en-US" sz="1300" i="1" dirty="0">
+                <a:solidFill>
                   <a:srgbClr val="A9B6D3"/>
                 </a:solidFill>
                 <a:latin typeface="Alexandria" pitchFamily="34" charset="0"/>
                 <a:ea typeface="Alexandria" pitchFamily="34" charset="-122"/>
                 <a:cs typeface="Alexandria" pitchFamily="34" charset="-120"/>
               </a:rPr>
-              <a:t>Mỗi bên ghi thêm điều họ quan tâm chính:</a:t>
-            </a:r>
-            <a:endParaRPr lang="en-US" sz="1600" dirty="0"/>
-          </a:p>
-        </p:txBody>
-      </p:sp>
-      <p:sp>
-        <p:nvSpPr>
-          <p:cNvPr id="11" name="Text 9"/>
-          <p:cNvSpPr txBox="1"/>
-          <p:nvPr/>
-        </p:nvSpPr>
-        <p:spPr>
-          <a:xfrm>
-            <a:off x="7726680" y="2697480"/>
-            <a:ext cx="3749040" cy="2651760"/>
-          </a:xfrm>
-          <a:prstGeom prst="rect">
-            <a:avLst/>
-          </a:prstGeom>
-          <a:noFill/>
-          <a:ln/>
-        </p:spPr>
-        <p:txBody>
-          <a:bodyPr wrap="square" lIns="635" tIns="635" rIns="635" bIns="635" rtlCol="0" anchor="t"/>
-          <a:lstStyle/>
-          <a:p>
-            <a:pPr indent="0" marL="0">
-              <a:spcAft>
-                <a:spcPts val="1000"/>
-              </a:spcAft>
-              <a:buNone/>
-            </a:pPr>
-            <a:r>
-              <a:rPr lang="en-US" sz="1600" b="1" dirty="0">
-                <a:solidFill>
-                  <a:srgbClr val="09A1E5"/>
-                </a:solidFill>
-                <a:latin typeface="Alexandria" pitchFamily="34" charset="0"/>
-                <a:ea typeface="Alexandria" pitchFamily="34" charset="-122"/>
-                <a:cs typeface="Alexandria" pitchFamily="34" charset="-120"/>
-              </a:rPr>
-              <a:t>Outputs</a:t>
-            </a:r>
-            <a:pPr indent="0" marL="0">
-              <a:spcAft>
-                <a:spcPts val="1000"/>
-              </a:spcAft>
-              <a:buNone/>
-            </a:pPr>
-            <a:r>
-              <a:rPr lang="en-US" sz="1600" dirty="0">
-                <a:solidFill>
-                  <a:srgbClr val="FBFAF4"/>
-                </a:solidFill>
-                <a:latin typeface="Alexandria" pitchFamily="34" charset="0"/>
-                <a:ea typeface="Alexandria" pitchFamily="34" charset="-122"/>
-                <a:cs typeface="Alexandria" pitchFamily="34" charset="-120"/>
-              </a:rPr>
-              <a:t> — kết quả đo được (số khách, doanh thu)</a:t>
-            </a:r>
-            <a:endParaRPr lang="en-US" sz="1600" dirty="0"/>
-          </a:p>
-          <a:p>
-            <a:pPr indent="0" marL="0">
-              <a:spcAft>
-                <a:spcPts val="1000"/>
-              </a:spcAft>
-              <a:buNone/>
-            </a:pPr>
-            <a:r>
-              <a:rPr lang="en-US" sz="1600" b="1" dirty="0">
-                <a:solidFill>
-                  <a:srgbClr val="FF9259"/>
-                </a:solidFill>
-                <a:latin typeface="Alexandria" pitchFamily="34" charset="0"/>
-                <a:ea typeface="Alexandria" pitchFamily="34" charset="-122"/>
-                <a:cs typeface="Alexandria" pitchFamily="34" charset="-120"/>
-              </a:rPr>
-              <a:t>Outcomes</a:t>
-            </a:r>
-            <a:pPr indent="0" marL="0">
-              <a:spcAft>
-                <a:spcPts val="1000"/>
-              </a:spcAft>
-              <a:buNone/>
-            </a:pPr>
-            <a:r>
-              <a:rPr lang="en-US" sz="1600" dirty="0">
-                <a:solidFill>
-                  <a:srgbClr val="FBFAF4"/>
-                </a:solidFill>
-                <a:latin typeface="Alexandria" pitchFamily="34" charset="0"/>
-                <a:ea typeface="Alexandria" pitchFamily="34" charset="-122"/>
-                <a:cs typeface="Alexandria" pitchFamily="34" charset="-120"/>
-              </a:rPr>
-              <a:t> — tác động định tính (hình ảnh, cộng đồng, trải nghiệm)</a:t>
-            </a:r>
-            <a:endParaRPr lang="en-US" sz="1600" dirty="0"/>
-          </a:p>
-        </p:txBody>
-      </p:sp>
-      <p:sp>
-        <p:nvSpPr>
-          <p:cNvPr id="12" name="Text 10"/>
+              <a:t>(ví dụ minh họa của Drakeley, 2022)</a:t>
+            </a:r>
+            <a:endParaRPr lang="en-US" sz="1300" dirty="0"/>
+          </a:p>
+        </p:txBody>
+      </p:sp>
+      <p:sp>
+        <p:nvSpPr>
+          <p:cNvPr id="22" name="Text 20"/>
           <p:cNvSpPr txBox="1"/>
           <p:nvPr/>
         </p:nvSpPr>
@@ -27792,7 +28111,7 @@
                 <a:ea typeface="Alexandria" pitchFamily="34" charset="-122"/>
                 <a:cs typeface="Alexandria" pitchFamily="34" charset="-120"/>
               </a:rPr>
-              <a:t>Nguồn: Wallace &amp; Michopoulou (2019), Event Management.</a:t>
+              <a:t>Nguồn: Wallace &amp; Michopoulou (2019); ví dụ theo Drakeley (2022).</a:t>
             </a:r>
             <a:endParaRPr lang="en-US" sz="1200" dirty="0"/>
           </a:p>
@@ -29879,7 +30198,7 @@
                 <a:ea typeface="Alexandria" pitchFamily="34" charset="-122"/>
                 <a:cs typeface="Alexandria" pitchFamily="34" charset="-120"/>
               </a:rPr>
-              <a:t>Một lời hứa với bên liên quan là một cam kết — có hợp đồng hay không</a:t>
+              <a:t>Đạo đức với bên liên quan: lắng nghe, thông tin, thích ứng — và chỉ hứa điều làm được</a:t>
             </a:r>
             <a:endParaRPr lang="en-US" sz="2800" dirty="0"/>
           </a:p>
@@ -29887,18 +30206,57 @@
       </p:sp>
       <p:sp>
         <p:nvSpPr>
-          <p:cNvPr id="3" name="Shape 1"/>
+          <p:cNvPr id="3" name="Text 1"/>
+          <p:cNvSpPr txBox="1"/>
+          <p:nvPr/>
+        </p:nvSpPr>
+        <p:spPr>
+          <a:xfrm>
+            <a:off x="548640" y="1645920"/>
+            <a:ext cx="6035040" cy="457200"/>
+          </a:xfrm>
+          <a:prstGeom prst="rect">
+            <a:avLst/>
+          </a:prstGeom>
+          <a:noFill/>
+          <a:ln/>
+        </p:spPr>
+        <p:txBody>
+          <a:bodyPr wrap="square" lIns="635" tIns="635" rIns="635" bIns="635" rtlCol="0" anchor="ctr"/>
+          <a:lstStyle/>
+          <a:p>
+            <a:pPr indent="0" marL="0">
+              <a:buNone/>
+            </a:pPr>
+            <a:r>
+              <a:rPr lang="en-US" sz="1600" b="1" dirty="0">
+                <a:solidFill>
+                  <a:srgbClr val="49B296"/>
+                </a:solidFill>
+                <a:latin typeface="Alexandria" pitchFamily="34" charset="0"/>
+                <a:ea typeface="Alexandria" pitchFamily="34" charset="-122"/>
+                <a:cs typeface="Alexandria" pitchFamily="34" charset="-120"/>
+              </a:rPr>
+              <a:t>Nguyên tắc Clarkson về quản trị bên liên quan</a:t>
+            </a:r>
+            <a:endParaRPr lang="en-US" sz="1600" dirty="0"/>
+          </a:p>
+        </p:txBody>
+      </p:sp>
+      <p:sp>
+        <p:nvSpPr>
+          <p:cNvPr id="4" name="Shape 2"/>
           <p:cNvSpPr/>
           <p:nvPr/>
         </p:nvSpPr>
         <p:spPr>
           <a:xfrm>
-            <a:off x="548640" y="1783080"/>
-            <a:ext cx="5486400" cy="2468880"/>
+            <a:off x="548640" y="2148840"/>
+            <a:ext cx="6035040" cy="731520"/>
           </a:xfrm>
           <a:prstGeom prst="roundRect">
             <a:avLst>
-              <a:gd name="adj" fmla="val 2963"/>
+              <a:gd name="adj" fmla="val 10000"/>
             </a:avLst>
           </a:prstGeom>
           <a:solidFill>
@@ -29914,14 +30272,14 @@
       </p:sp>
       <p:sp>
         <p:nvSpPr>
-          <p:cNvPr id="4" name="Shape 2"/>
+          <p:cNvPr id="5" name="Shape 3"/>
           <p:cNvSpPr/>
           <p:nvPr/>
         </p:nvSpPr>
         <p:spPr>
           <a:xfrm>
-            <a:off x="777240" y="2011680"/>
-            <a:ext cx="777240" cy="777240"/>
+            <a:off x="685800" y="2240280"/>
+            <a:ext cx="548640" cy="548640"/>
           </a:xfrm>
           <a:prstGeom prst="ellipse">
             <a:avLst/>
@@ -29939,7 +30297,7 @@
       </p:sp>
       <p:pic>
         <p:nvPicPr>
-          <p:cNvPr id="5" name="Image 0" descr="preencoded.png">    </p:cNvPr>
+          <p:cNvPr id="6" name="Image 0" descr="preencoded.png">    </p:cNvPr>
           <p:cNvPicPr>
             <a:picLocks noChangeAspect="1"/>
           </p:cNvPicPr>
@@ -29953,8 +30311,8 @@
         </p:blipFill>
         <p:spPr>
           <a:xfrm>
-            <a:off x="948233" y="2182673"/>
-            <a:ext cx="435254" cy="435254"/>
+            <a:off x="806501" y="2360981"/>
+            <a:ext cx="307238" cy="307238"/>
           </a:xfrm>
           <a:prstGeom prst="rect">
             <a:avLst/>
@@ -29963,14 +30321,14 @@
       </p:pic>
       <p:sp>
         <p:nvSpPr>
-          <p:cNvPr id="6" name="Text 3"/>
-          <p:cNvSpPr txBox="1"/>
-          <p:nvPr/>
-        </p:nvSpPr>
-        <p:spPr>
-          <a:xfrm>
-            <a:off x="1737360" y="2011680"/>
-            <a:ext cx="4114800" cy="777240"/>
+          <p:cNvPr id="7" name="Text 4"/>
+          <p:cNvSpPr txBox="1"/>
+          <p:nvPr/>
+        </p:nvSpPr>
+        <p:spPr>
+          <a:xfrm>
+            <a:off x="1371600" y="2148840"/>
+            <a:ext cx="5120640" cy="731520"/>
           </a:xfrm>
           <a:prstGeom prst="rect">
             <a:avLst/>
@@ -29986,46 +30344,7 @@
               <a:buNone/>
             </a:pPr>
             <a:r>
-              <a:rPr lang="en-US" sz="2000" b="1" dirty="0">
-                <a:solidFill>
-                  <a:srgbClr val="49B296"/>
-                </a:solidFill>
-                <a:latin typeface="Alexandria" pitchFamily="34" charset="0"/>
-                <a:ea typeface="Alexandria" pitchFamily="34" charset="-122"/>
-                <a:cs typeface="Alexandria" pitchFamily="34" charset="-120"/>
-              </a:rPr>
-              <a:t>Có hợp đồng</a:t>
-            </a:r>
-            <a:endParaRPr lang="en-US" sz="2000" dirty="0"/>
-          </a:p>
-        </p:txBody>
-      </p:sp>
-      <p:sp>
-        <p:nvSpPr>
-          <p:cNvPr id="7" name="Text 4"/>
-          <p:cNvSpPr txBox="1"/>
-          <p:nvPr/>
-        </p:nvSpPr>
-        <p:spPr>
-          <a:xfrm>
-            <a:off x="777240" y="2971800"/>
-            <a:ext cx="5029200" cy="1645920"/>
-          </a:xfrm>
-          <a:prstGeom prst="rect">
-            <a:avLst/>
-          </a:prstGeom>
-          <a:noFill/>
-          <a:ln/>
-        </p:spPr>
-        <p:txBody>
-          <a:bodyPr wrap="square" lIns="635" tIns="635" rIns="635" bIns="635" rtlCol="0" anchor="t"/>
-          <a:lstStyle/>
-          <a:p>
-            <a:pPr indent="0" marL="0">
-              <a:buNone/>
-            </a:pPr>
-            <a:r>
-              <a:rPr lang="en-US" sz="1800" dirty="0">
+              <a:rPr lang="en-US" sz="1600" dirty="0">
                 <a:solidFill>
                   <a:srgbClr val="FBFAF4"/>
                 </a:solidFill>
@@ -30033,9 +30352,9 @@
                 <a:ea typeface="Alexandria" pitchFamily="34" charset="-122"/>
                 <a:cs typeface="Alexandria" pitchFamily="34" charset="-120"/>
               </a:rPr>
-              <a:t>Quyền lợi ghi rõ; bên kia có thể đòi theo luật.</a:t>
-            </a:r>
-            <a:endParaRPr lang="en-US" sz="1800" dirty="0"/>
+              <a:t>Thừa nhận và theo dõi chủ động các bên</a:t>
+            </a:r>
+            <a:endParaRPr lang="en-US" sz="1600" dirty="0"/>
           </a:p>
         </p:txBody>
       </p:sp>
@@ -30047,12 +30366,12 @@
         </p:nvSpPr>
         <p:spPr>
           <a:xfrm>
-            <a:off x="6263640" y="1783080"/>
-            <a:ext cx="5376672" cy="2468880"/>
+            <a:off x="548640" y="3017520"/>
+            <a:ext cx="6035040" cy="731520"/>
           </a:xfrm>
           <a:prstGeom prst="roundRect">
             <a:avLst>
-              <a:gd name="adj" fmla="val 2963"/>
+              <a:gd name="adj" fmla="val 10000"/>
             </a:avLst>
           </a:prstGeom>
           <a:solidFill>
@@ -30074,18 +30393,18 @@
         </p:nvSpPr>
         <p:spPr>
           <a:xfrm>
-            <a:off x="6492240" y="2011680"/>
-            <a:ext cx="777240" cy="777240"/>
+            <a:off x="685800" y="3108960"/>
+            <a:ext cx="548640" cy="548640"/>
           </a:xfrm>
           <a:prstGeom prst="ellipse">
             <a:avLst/>
           </a:prstGeom>
           <a:solidFill>
-            <a:srgbClr val="FF5178"/>
+            <a:srgbClr val="49B296"/>
           </a:solidFill>
           <a:ln w="12700">
             <a:solidFill>
-              <a:srgbClr val="FF5178"/>
+              <a:srgbClr val="49B296"/>
             </a:solidFill>
             <a:prstDash val="solid"/>
           </a:ln>
@@ -30107,8 +30426,8 @@
         </p:blipFill>
         <p:spPr>
           <a:xfrm>
-            <a:off x="6663233" y="2182673"/>
-            <a:ext cx="435254" cy="435254"/>
+            <a:off x="806501" y="3229661"/>
+            <a:ext cx="307238" cy="307238"/>
           </a:xfrm>
           <a:prstGeom prst="rect">
             <a:avLst/>
@@ -30123,8 +30442,8 @@
         </p:nvSpPr>
         <p:spPr>
           <a:xfrm>
-            <a:off x="7452360" y="2011680"/>
-            <a:ext cx="4023360" cy="777240"/>
+            <a:off x="1371600" y="3017520"/>
+            <a:ext cx="5120640" cy="731520"/>
           </a:xfrm>
           <a:prstGeom prst="rect">
             <a:avLst/>
@@ -30140,30 +30459,326 @@
               <a:buNone/>
             </a:pPr>
             <a:r>
-              <a:rPr lang="en-US" sz="2000" b="1" dirty="0">
-                <a:solidFill>
-                  <a:srgbClr val="FF5178"/>
-                </a:solidFill>
-                <a:latin typeface="Alexandria" pitchFamily="34" charset="0"/>
-                <a:ea typeface="Alexandria" pitchFamily="34" charset="-122"/>
-                <a:cs typeface="Alexandria" pitchFamily="34" charset="-120"/>
-              </a:rPr>
-              <a:t>Chỉ là lời hứa</a:t>
-            </a:r>
-            <a:endParaRPr lang="en-US" sz="2000" dirty="0"/>
-          </a:p>
-        </p:txBody>
-      </p:sp>
-      <p:sp>
-        <p:nvSpPr>
-          <p:cNvPr id="12" name="Text 8"/>
-          <p:cNvSpPr txBox="1"/>
-          <p:nvPr/>
-        </p:nvSpPr>
-        <p:spPr>
-          <a:xfrm>
-            <a:off x="6492240" y="2971800"/>
-            <a:ext cx="4937760" cy="1645920"/>
+              <a:rPr lang="en-US" sz="1600" dirty="0">
+                <a:solidFill>
+                  <a:srgbClr val="FBFAF4"/>
+                </a:solidFill>
+                <a:latin typeface="Alexandria" pitchFamily="34" charset="0"/>
+                <a:ea typeface="Alexandria" pitchFamily="34" charset="-122"/>
+                <a:cs typeface="Alexandria" pitchFamily="34" charset="-120"/>
+              </a:rPr>
+              <a:t>Lắng nghe và trao đổi với họ</a:t>
+            </a:r>
+            <a:endParaRPr lang="en-US" sz="1600" dirty="0"/>
+          </a:p>
+        </p:txBody>
+      </p:sp>
+      <p:sp>
+        <p:nvSpPr>
+          <p:cNvPr id="12" name="Shape 8"/>
+          <p:cNvSpPr/>
+          <p:nvPr/>
+        </p:nvSpPr>
+        <p:spPr>
+          <a:xfrm>
+            <a:off x="548640" y="3886200"/>
+            <a:ext cx="6035040" cy="731520"/>
+          </a:xfrm>
+          <a:prstGeom prst="roundRect">
+            <a:avLst>
+              <a:gd name="adj" fmla="val 10000"/>
+            </a:avLst>
+          </a:prstGeom>
+          <a:solidFill>
+            <a:srgbClr val="22395F"/>
+          </a:solidFill>
+          <a:ln w="12700">
+            <a:solidFill>
+              <a:srgbClr val="22395F"/>
+            </a:solidFill>
+            <a:prstDash val="solid"/>
+          </a:ln>
+        </p:spPr>
+      </p:sp>
+      <p:sp>
+        <p:nvSpPr>
+          <p:cNvPr id="13" name="Shape 9"/>
+          <p:cNvSpPr/>
+          <p:nvPr/>
+        </p:nvSpPr>
+        <p:spPr>
+          <a:xfrm>
+            <a:off x="685800" y="3977640"/>
+            <a:ext cx="548640" cy="548640"/>
+          </a:xfrm>
+          <a:prstGeom prst="ellipse">
+            <a:avLst/>
+          </a:prstGeom>
+          <a:solidFill>
+            <a:srgbClr val="49B296"/>
+          </a:solidFill>
+          <a:ln w="12700">
+            <a:solidFill>
+              <a:srgbClr val="49B296"/>
+            </a:solidFill>
+            <a:prstDash val="solid"/>
+          </a:ln>
+        </p:spPr>
+      </p:sp>
+      <p:pic>
+        <p:nvPicPr>
+          <p:cNvPr id="14" name="Image 2" descr="preencoded.png">    </p:cNvPr>
+          <p:cNvPicPr>
+            <a:picLocks noChangeAspect="1"/>
+          </p:cNvPicPr>
+          <p:nvPr/>
+        </p:nvPicPr>
+        <p:blipFill>
+          <a:blip r:embed="rId3"/>
+          <a:stretch>
+            <a:fillRect/>
+          </a:stretch>
+        </p:blipFill>
+        <p:spPr>
+          <a:xfrm>
+            <a:off x="806501" y="4098341"/>
+            <a:ext cx="307238" cy="307238"/>
+          </a:xfrm>
+          <a:prstGeom prst="rect">
+            <a:avLst/>
+          </a:prstGeom>
+        </p:spPr>
+      </p:pic>
+      <p:sp>
+        <p:nvSpPr>
+          <p:cNvPr id="15" name="Text 10"/>
+          <p:cNvSpPr txBox="1"/>
+          <p:nvPr/>
+        </p:nvSpPr>
+        <p:spPr>
+          <a:xfrm>
+            <a:off x="1371600" y="3886200"/>
+            <a:ext cx="5120640" cy="731520"/>
+          </a:xfrm>
+          <a:prstGeom prst="rect">
+            <a:avLst/>
+          </a:prstGeom>
+          <a:noFill/>
+          <a:ln/>
+        </p:spPr>
+        <p:txBody>
+          <a:bodyPr wrap="square" lIns="635" tIns="635" rIns="635" bIns="635" rtlCol="0" anchor="ctr"/>
+          <a:lstStyle/>
+          <a:p>
+            <a:pPr indent="0" marL="0">
+              <a:buNone/>
+            </a:pPr>
+            <a:r>
+              <a:rPr lang="en-US" sz="1600" dirty="0">
+                <a:solidFill>
+                  <a:srgbClr val="FBFAF4"/>
+                </a:solidFill>
+                <a:latin typeface="Alexandria" pitchFamily="34" charset="0"/>
+                <a:ea typeface="Alexandria" pitchFamily="34" charset="-122"/>
+                <a:cs typeface="Alexandria" pitchFamily="34" charset="-120"/>
+              </a:rPr>
+              <a:t>Điều chỉnh hành vi theo nhu cầu của họ</a:t>
+            </a:r>
+            <a:endParaRPr lang="en-US" sz="1600" dirty="0"/>
+          </a:p>
+        </p:txBody>
+      </p:sp>
+      <p:sp>
+        <p:nvSpPr>
+          <p:cNvPr id="16" name="Shape 11"/>
+          <p:cNvSpPr/>
+          <p:nvPr/>
+        </p:nvSpPr>
+        <p:spPr>
+          <a:xfrm>
+            <a:off x="548640" y="4754880"/>
+            <a:ext cx="6035040" cy="731520"/>
+          </a:xfrm>
+          <a:prstGeom prst="roundRect">
+            <a:avLst>
+              <a:gd name="adj" fmla="val 10000"/>
+            </a:avLst>
+          </a:prstGeom>
+          <a:solidFill>
+            <a:srgbClr val="22395F"/>
+          </a:solidFill>
+          <a:ln w="12700">
+            <a:solidFill>
+              <a:srgbClr val="22395F"/>
+            </a:solidFill>
+            <a:prstDash val="solid"/>
+          </a:ln>
+        </p:spPr>
+      </p:sp>
+      <p:sp>
+        <p:nvSpPr>
+          <p:cNvPr id="17" name="Shape 12"/>
+          <p:cNvSpPr/>
+          <p:nvPr/>
+        </p:nvSpPr>
+        <p:spPr>
+          <a:xfrm>
+            <a:off x="685800" y="4846320"/>
+            <a:ext cx="548640" cy="548640"/>
+          </a:xfrm>
+          <a:prstGeom prst="ellipse">
+            <a:avLst/>
+          </a:prstGeom>
+          <a:solidFill>
+            <a:srgbClr val="49B296"/>
+          </a:solidFill>
+          <a:ln w="12700">
+            <a:solidFill>
+              <a:srgbClr val="49B296"/>
+            </a:solidFill>
+            <a:prstDash val="solid"/>
+          </a:ln>
+        </p:spPr>
+      </p:sp>
+      <p:pic>
+        <p:nvPicPr>
+          <p:cNvPr id="18" name="Image 3" descr="preencoded.png">    </p:cNvPr>
+          <p:cNvPicPr>
+            <a:picLocks noChangeAspect="1"/>
+          </p:cNvPicPr>
+          <p:nvPr/>
+        </p:nvPicPr>
+        <p:blipFill>
+          <a:blip r:embed="rId4"/>
+          <a:stretch>
+            <a:fillRect/>
+          </a:stretch>
+        </p:blipFill>
+        <p:spPr>
+          <a:xfrm>
+            <a:off x="806501" y="4967021"/>
+            <a:ext cx="307238" cy="307238"/>
+          </a:xfrm>
+          <a:prstGeom prst="rect">
+            <a:avLst/>
+          </a:prstGeom>
+        </p:spPr>
+      </p:pic>
+      <p:sp>
+        <p:nvSpPr>
+          <p:cNvPr id="19" name="Text 13"/>
+          <p:cNvSpPr txBox="1"/>
+          <p:nvPr/>
+        </p:nvSpPr>
+        <p:spPr>
+          <a:xfrm>
+            <a:off x="1371600" y="4754880"/>
+            <a:ext cx="5120640" cy="731520"/>
+          </a:xfrm>
+          <a:prstGeom prst="rect">
+            <a:avLst/>
+          </a:prstGeom>
+          <a:noFill/>
+          <a:ln/>
+        </p:spPr>
+        <p:txBody>
+          <a:bodyPr wrap="square" lIns="635" tIns="635" rIns="635" bIns="635" rtlCol="0" anchor="ctr"/>
+          <a:lstStyle/>
+          <a:p>
+            <a:pPr indent="0" marL="0">
+              <a:buNone/>
+            </a:pPr>
+            <a:r>
+              <a:rPr lang="en-US" sz="1600" dirty="0">
+                <a:solidFill>
+                  <a:srgbClr val="FBFAF4"/>
+                </a:solidFill>
+                <a:latin typeface="Alexandria" pitchFamily="34" charset="0"/>
+                <a:ea typeface="Alexandria" pitchFamily="34" charset="-122"/>
+                <a:cs typeface="Alexandria" pitchFamily="34" charset="-120"/>
+              </a:rPr>
+              <a:t>Thừa nhận sự phụ thuộc lẫn nhau, coi trọng hợp tác</a:t>
+            </a:r>
+            <a:endParaRPr lang="en-US" sz="1600" dirty="0"/>
+          </a:p>
+        </p:txBody>
+      </p:sp>
+      <p:sp>
+        <p:nvSpPr>
+          <p:cNvPr id="20" name="Shape 14"/>
+          <p:cNvSpPr/>
+          <p:nvPr/>
+        </p:nvSpPr>
+        <p:spPr>
+          <a:xfrm>
+            <a:off x="6858000" y="1783080"/>
+            <a:ext cx="4782312" cy="3611880"/>
+          </a:xfrm>
+          <a:prstGeom prst="roundRect">
+            <a:avLst>
+              <a:gd name="adj" fmla="val 2025"/>
+            </a:avLst>
+          </a:prstGeom>
+          <a:solidFill>
+            <a:srgbClr val="FFD23B"/>
+          </a:solidFill>
+          <a:ln w="12700">
+            <a:solidFill>
+              <a:srgbClr val="FFD23B"/>
+            </a:solidFill>
+            <a:prstDash val="solid"/>
+          </a:ln>
+        </p:spPr>
+      </p:sp>
+      <p:sp>
+        <p:nvSpPr>
+          <p:cNvPr id="21" name="Text 15"/>
+          <p:cNvSpPr txBox="1"/>
+          <p:nvPr/>
+        </p:nvSpPr>
+        <p:spPr>
+          <a:xfrm>
+            <a:off x="7086600" y="1920240"/>
+            <a:ext cx="4389120" cy="914400"/>
+          </a:xfrm>
+          <a:prstGeom prst="rect">
+            <a:avLst/>
+          </a:prstGeom>
+          <a:noFill/>
+          <a:ln/>
+        </p:spPr>
+        <p:txBody>
+          <a:bodyPr wrap="square" lIns="635" tIns="635" rIns="635" bIns="635" rtlCol="0" anchor="ctr"/>
+          <a:lstStyle/>
+          <a:p>
+            <a:pPr indent="0" marL="0">
+              <a:buNone/>
+            </a:pPr>
+            <a:r>
+              <a:rPr lang="en-US" sz="1900" b="1" i="1" dirty="0">
+                <a:solidFill>
+                  <a:srgbClr val="172849"/>
+                </a:solidFill>
+                <a:latin typeface="Alexandria" pitchFamily="34" charset="0"/>
+                <a:ea typeface="Alexandria" pitchFamily="34" charset="-122"/>
+                <a:cs typeface="Alexandria" pitchFamily="34" charset="-120"/>
+              </a:rPr>
+              <a:t>“Họ hứa 200.000 người… Họ đâu rồi?”</a:t>
+            </a:r>
+            <a:endParaRPr lang="en-US" sz="1900" dirty="0"/>
+          </a:p>
+        </p:txBody>
+      </p:sp>
+      <p:sp>
+        <p:nvSpPr>
+          <p:cNvPr id="22" name="Text 16"/>
+          <p:cNvSpPr txBox="1"/>
+          <p:nvPr/>
+        </p:nvSpPr>
+        <p:spPr>
+          <a:xfrm>
+            <a:off x="7086600" y="2880360"/>
+            <a:ext cx="4389120" cy="2377440"/>
           </a:xfrm>
           <a:prstGeom prst="rect">
             <a:avLst/>
@@ -30179,30 +30794,30 @@
               <a:buNone/>
             </a:pPr>
             <a:r>
-              <a:rPr lang="en-US" sz="1800" dirty="0">
-                <a:solidFill>
-                  <a:srgbClr val="FBFAF4"/>
-                </a:solidFill>
-                <a:latin typeface="Alexandria" pitchFamily="34" charset="0"/>
-                <a:ea typeface="Alexandria" pitchFamily="34" charset="-122"/>
-                <a:cs typeface="Alexandria" pitchFamily="34" charset="-120"/>
-              </a:rPr>
-              <a:t>Không kiện được — nhưng mất uy tín. “Họ hứa 200.000 người…”</a:t>
-            </a:r>
-            <a:endParaRPr lang="en-US" sz="1800" dirty="0"/>
-          </a:p>
-        </p:txBody>
-      </p:sp>
-      <p:sp>
-        <p:nvSpPr>
-          <p:cNvPr id="13" name="Text 9"/>
-          <p:cNvSpPr txBox="1"/>
-          <p:nvPr/>
-        </p:nvSpPr>
-        <p:spPr>
-          <a:xfrm>
-            <a:off x="548640" y="4572000"/>
-            <a:ext cx="11091672" cy="640080"/>
+              <a:rPr lang="en-US" sz="1700" dirty="0">
+                <a:solidFill>
+                  <a:srgbClr val="172849"/>
+                </a:solidFill>
+                <a:latin typeface="Alexandria" pitchFamily="34" charset="0"/>
+                <a:ea typeface="Alexandria" pitchFamily="34" charset="-122"/>
+                <a:cs typeface="Alexandria" pitchFamily="34" charset="-120"/>
+              </a:rPr>
+              <a:t>Lời hứa không có hợp đồng thì không kiện được — nhưng mất uy tín. Chỉ hứa điều mình kiểm soát được; ghi lại điều đã hứa.</a:t>
+            </a:r>
+            <a:endParaRPr lang="en-US" sz="1700" dirty="0"/>
+          </a:p>
+        </p:txBody>
+      </p:sp>
+      <p:sp>
+        <p:nvSpPr>
+          <p:cNvPr id="23" name="Text 17"/>
+          <p:cNvSpPr txBox="1"/>
+          <p:nvPr/>
+        </p:nvSpPr>
+        <p:spPr>
+          <a:xfrm>
+            <a:off x="548640" y="5715000"/>
+            <a:ext cx="10424160" cy="365760"/>
           </a:xfrm>
           <a:prstGeom prst="rect">
             <a:avLst/>
@@ -30218,17 +30833,17 @@
               <a:buNone/>
             </a:pPr>
             <a:r>
-              <a:rPr lang="en-US" sz="2200" b="1" dirty="0">
-                <a:solidFill>
-                  <a:srgbClr val="FFD23B"/>
-                </a:solidFill>
-                <a:latin typeface="Alexandria" pitchFamily="34" charset="0"/>
-                <a:ea typeface="Alexandria" pitchFamily="34" charset="-122"/>
-                <a:cs typeface="Alexandria" pitchFamily="34" charset="-120"/>
-              </a:rPr>
-              <a:t>Chỉ hứa điều mình kiểm soát được; ghi lại điều đã hứa.</a:t>
-            </a:r>
-            <a:endParaRPr lang="en-US" sz="2200" dirty="0"/>
+              <a:rPr lang="en-US" sz="1200" i="1" dirty="0">
+                <a:solidFill>
+                  <a:srgbClr val="A9B6D3"/>
+                </a:solidFill>
+                <a:latin typeface="Alexandria" pitchFamily="34" charset="0"/>
+                <a:ea typeface="Alexandria" pitchFamily="34" charset="-122"/>
+                <a:cs typeface="Alexandria" pitchFamily="34" charset="-120"/>
+              </a:rPr>
+              <a:t>Nguồn: Clarkson Principles (Maines, 2018), dẫn theo Drakeley (2022); Holmes et al. (2015, tr. 30).</a:t>
+            </a:r>
+            <a:endParaRPr lang="en-US" sz="1200" dirty="0"/>
           </a:p>
         </p:txBody>
       </p:sp>
@@ -33193,6 +33808,60 @@
                 <a:cs typeface="Alexandria" pitchFamily="34" charset="-120"/>
               </a:rPr>
               <a:t>(1), 92–117.</a:t>
+            </a:r>
+            <a:endParaRPr lang="en-US" sz="1200" dirty="0"/>
+          </a:p>
+          <a:p>
+            <a:pPr indent="0" marL="0">
+              <a:spcAft>
+                <a:spcPts val="400"/>
+              </a:spcAft>
+              <a:buNone/>
+            </a:pPr>
+            <a:r>
+              <a:rPr lang="en-US" sz="1200" dirty="0">
+                <a:solidFill>
+                  <a:srgbClr val="FBFAF4"/>
+                </a:solidFill>
+                <a:latin typeface="Alexandria" pitchFamily="34" charset="0"/>
+                <a:ea typeface="Alexandria" pitchFamily="34" charset="-122"/>
+                <a:cs typeface="Alexandria" pitchFamily="34" charset="-120"/>
+              </a:rPr>
+              <a:t>Drakeley, C. (2022). </a:t>
+            </a:r>
+            <a:pPr indent="0" marL="0">
+              <a:spcAft>
+                <a:spcPts val="400"/>
+              </a:spcAft>
+              <a:buNone/>
+            </a:pPr>
+            <a:r>
+              <a:rPr lang="en-US" sz="1200" i="1" dirty="0">
+                <a:solidFill>
+                  <a:srgbClr val="FBFAF4"/>
+                </a:solidFill>
+                <a:latin typeface="Alexandria" pitchFamily="34" charset="0"/>
+                <a:ea typeface="Alexandria" pitchFamily="34" charset="-122"/>
+                <a:cs typeface="Alexandria" pitchFamily="34" charset="-120"/>
+              </a:rPr>
+              <a:t>Managing event stakeholders: Expect the unexpected</a:t>
+            </a:r>
+            <a:pPr indent="0" marL="0">
+              <a:spcAft>
+                <a:spcPts val="400"/>
+              </a:spcAft>
+              <a:buNone/>
+            </a:pPr>
+            <a:r>
+              <a:rPr lang="en-US" sz="1200" dirty="0">
+                <a:solidFill>
+                  <a:srgbClr val="FBFAF4"/>
+                </a:solidFill>
+                <a:latin typeface="Alexandria" pitchFamily="34" charset="0"/>
+                <a:ea typeface="Alexandria" pitchFamily="34" charset="-122"/>
+                <a:cs typeface="Alexandria" pitchFamily="34" charset="-120"/>
+              </a:rPr>
+              <a:t> [Chương sách].</a:t>
             </a:r>
             <a:endParaRPr lang="en-US" sz="1200" dirty="0"/>
           </a:p>

</xml_diff>